<commit_message>
added names and reg no. and springer style report
</commit_message>
<xml_diff>
--- a/presentation/SQLi_Defence_Lab.pptx
+++ b/presentation/SQLi_Defence_Lab.pptx
@@ -3259,6 +3259,25 @@
                 <a:spcPts val="0"/>
               </a:spcBef>
               <a:spcAft>
+                <a:spcPts val="200"/>
+              </a:spcAft>
+            </a:pPr>
+            <a:r>
+              <a:rPr sz="1500" b="0" i="0">
+                <a:solidFill>
+                  <a:srgbClr val="ECEFF3"/>
+                </a:solidFill>
+                <a:latin typeface="Segoe UI"/>
+              </a:rPr>
+              <a:t>YashVardhan Gupta · 230905442      Sheldon Rodricks · 230905324</a:t>
+            </a:r>
+          </a:p>
+          <a:p>
+            <a:pPr algn="l">
+              <a:spcBef>
+                <a:spcPts val="0"/>
+              </a:spcBef>
+              <a:spcAft>
                 <a:spcPts val="400"/>
               </a:spcAft>
             </a:pPr>
@@ -3269,7 +3288,7 @@
                 </a:solidFill>
                 <a:latin typeface="Segoe UI"/>
               </a:rPr>
-              <a:t>Members:  [Name 1 · RegNo]   [Name 2 · RegNo]   [Name 3 · RegNo]   [Name 4 · RegNo]</a:t>
+              <a:t>Lakshya Agrawal · 230905552      Aditya Aryan Sahu · 230905560</a:t>
             </a:r>
           </a:p>
           <a:p>

</xml_diff>